<commit_message>
Update quoted numbers to the accuracy run: deck, launch kit, industry plan, service doc, SVG, Space text
Hit@10 38.1% (was 35.6%), pool recall 65.3% (was 58.0%), MILP lambda=0.5
+14% realized profit (was +17% against the weaker first ranker). The old
run stays quoted as history where it explains the change.
</commit_message>
<xml_diff>
--- a/docs/deck/MarginGraph_pitch_deck.pptx
+++ b/docs/deck/MarginGraph_pitch_deck.pptx
@@ -121,23 +121,23 @@
   <p:extLst>
     <p:ext uri="{521415D9-36F7-43E2-AB2F-B90AF26B5E84}">
       <p14:sectionLst xmlns:p14="http://schemas.microsoft.com/office/powerpoint/2010/main">
-        <p14:section name="Opening" id="{bdf34344-dd1f-24e4-059a-198922a6fc69}">
+        <p14:section name="Opening" id="{d5e93613-ab4b-7fb3-3096-c1df4cdfe593}">
           <p14:sldIdLst>
             <p14:sldId id="256"/>
           </p14:sldIdLst>
         </p14:section>
-        <p14:section name="Problem and solution" id="{7ee7d0d8-2c66-2e50-2cde-b9ea638a89fa}">
+        <p14:section name="Problem and solution" id="{64c9fc9e-230a-cc78-f96b-ca828d8894c0}">
           <p14:sldIdLst>
             <p14:sldId id="257"/>
             <p14:sldId id="258"/>
           </p14:sldIdLst>
         </p14:section>
-        <p14:section name="How it works" id="{5df88757-0695-2fa4-1bb8-dd358e515a45}">
+        <p14:section name="How it works" id="{0c4803e0-5f9a-b498-a5de-53705abb4c61}">
           <p14:sldIdLst>
             <p14:sldId id="259"/>
           </p14:sldIdLst>
         </p14:section>
-        <p14:section name="Results" id="{7f09d576-9ebb-bfd5-02de-67ca1943ac28}">
+        <p14:section name="Results" id="{b927d42b-fbb6-8260-9988-cc39f52e9a1e}">
           <p14:sldIdLst>
             <p14:sldId id="260"/>
             <p14:sldId id="261"/>
@@ -146,20 +146,20 @@
             <p14:sldId id="264"/>
           </p14:sldIdLst>
         </p14:section>
-        <p14:section name="Product" id="{06b8aade-8039-9e6b-a18b-ffe1d967d022}">
+        <p14:section name="Product" id="{cc6acd20-74e7-ce24-6e18-4d032c0392b7}">
           <p14:sldIdLst>
             <p14:sldId id="265"/>
             <p14:sldId id="266"/>
           </p14:sldIdLst>
         </p14:section>
-        <p14:section name="Business and plan" id="{d494b806-5ae6-a968-e382-b7b57d7e1489}">
+        <p14:section name="Business and plan" id="{08a1cff4-16cd-483b-8942-ee81f1ebb871}">
           <p14:sldIdLst>
             <p14:sldId id="267"/>
             <p14:sldId id="268"/>
             <p14:sldId id="269"/>
           </p14:sldIdLst>
         </p14:section>
-        <p14:section name="Close" id="{a8a8e56d-c9ee-c802-0178-88d84a00f7e1}">
+        <p14:section name="Close" id="{c825e8ca-6577-3487-b55d-8bf62607aee0}">
           <p14:sldIdLst>
             <p14:sldId id="270"/>
           </p14:sldIdLst>
@@ -377,10 +377,10 @@
                   <c:v>3.1</c:v>
                 </c:pt>
                 <c:pt idx="1">
-                  <c:v>13.1</c:v>
+                  <c:v>13</c:v>
                 </c:pt>
                 <c:pt idx="2">
-                  <c:v>13.9</c:v>
+                  <c:v>13.4</c:v>
                 </c:pt>
                 <c:pt idx="3">
                   <c:v>17.3</c:v>
@@ -392,7 +392,7 @@
                   <c:v>31.1</c:v>
                 </c:pt>
                 <c:pt idx="6">
-                  <c:v>35.6</c:v>
+                  <c:v>38.1</c:v>
                 </c:pt>
               </c:numCache>
             </c:numRef>
@@ -709,16 +709,16 @@
                   <c:v>0.013</c:v>
                 </c:pt>
                 <c:pt idx="1">
-                  <c:v>0.07</c:v>
+                  <c:v>0.072</c:v>
                 </c:pt>
                 <c:pt idx="2">
-                  <c:v>0.184</c:v>
+                  <c:v>0.205</c:v>
                 </c:pt>
                 <c:pt idx="3">
-                  <c:v>0.215</c:v>
+                  <c:v>0.234</c:v>
                 </c:pt>
                 <c:pt idx="4">
-                  <c:v>0.224</c:v>
+                  <c:v>0.255</c:v>
                 </c:pt>
               </c:numCache>
             </c:numRef>
@@ -2222,7 +2222,7 @@
           <a:p>
             <a:r>
               <a:rPr lang="en-US" dirty="0"/>
-              <a:t>On 4,480 real test baskets the LightGBM ranker puts the hidden item in its top 10 35.6% of the time, against 31.1% for EASE, the strongest standard method. The gain of 4.5 points has a confidence interval well above zero.</a:t>
+              <a:t>On 4,480 real test baskets the LightGBM ranker puts the hidden item in its top 10 38.1% of the time, against 31.1% for EASE, the strongest standard method. The gain of 7.0 points has a confidence interval well above zero.</a:t>
             </a:r>
             <a:endParaRPr lang="en-US" dirty="0"/>
           </a:p>
@@ -2310,7 +2310,7 @@
           <a:p>
             <a:r>
               <a:rPr lang="en-US" dirty="0"/>
-              <a:t>Realized profit only counts the item the customer really bought. At lambda 0.5 the optimizer earns 17% more per basket than showing the ranker's top two, for about one point fewer hits, and with zero margin-floor breaks. Be clear: unit cost and stock were simulated because the public dataset does not include them.</a:t>
+              <a:t>Realized profit only counts the item the customer really bought. At lambda 0.5 the optimizer earns 14% more per basket than showing the ranker's top two, for about one point fewer hits, and with zero margin-floor breaks. Be clear: unit cost and stock were simulated because the public dataset does not include them.</a:t>
             </a:r>
             <a:endParaRPr lang="en-US" dirty="0"/>
           </a:p>
@@ -7075,7 +7075,7 @@
                   <a:schemeClr val="tx1"/>
                 </a:solidFill>
               </a:rPr>
-              <a:t>Relevance gain over standard methods (+4.5 pts Hit@10)</a:t>
+              <a:t>Relevance gain over standard methods (+7.0 pts Hit@10)</a:t>
             </a:r>
             <a:endParaRPr lang="en-US" sz="1500" dirty="0"/>
           </a:p>
@@ -7093,7 +7093,7 @@
                   <a:schemeClr val="tx1"/>
                 </a:solidFill>
               </a:rPr>
-              <a:t>Optimizer is exact and fast (600/600, 3.4 ms)</a:t>
+              <a:t>Optimizer is exact and fast (600/600, 2.7 ms)</a:t>
             </a:r>
             <a:endParaRPr lang="en-US" sz="1500" dirty="0"/>
           </a:p>
@@ -9720,7 +9720,7 @@
                   <a:schemeClr val="tx1"/>
                 </a:solidFill>
               </a:rPr>
-              <a:t>EASE, ItemKNN, ALS, repeat, co-purchase, popularity: up to 100 items</a:t>
+              <a:t>EASE (3 variants), text, fresh sales, ItemKNN, ALS, repeat, co-purchase, popularity: up to 150 items</a:t>
             </a:r>
             <a:endParaRPr lang="en-US" sz="1400" dirty="0"/>
           </a:p>
@@ -10988,7 +10988,7 @@
                 <a:ea typeface="Cambria" pitchFamily="34" charset="-122"/>
                 <a:cs typeface="Cambria" pitchFamily="34" charset="-120"/>
               </a:rPr>
-              <a:t>+4.5 pts</a:t>
+              <a:t>+7.0 pts</a:t>
             </a:r>
             <a:endParaRPr lang="en-US" sz="4800" dirty="0"/>
           </a:p>
@@ -11038,7 +11038,7 @@
                   <a:schemeClr val="accent5"/>
                 </a:solidFill>
               </a:rPr>
-              <a:t>95% CI [3.6, 5.5]</a:t>
+              <a:t>95% CI [6.0, 8.0]</a:t>
             </a:r>
             <a:endParaRPr lang="en-US" sz="1400" dirty="0"/>
           </a:p>
@@ -11077,7 +11077,7 @@
                 <a:ea typeface="Cambria" pitchFamily="34" charset="-122"/>
                 <a:cs typeface="Cambria" pitchFamily="34" charset="-120"/>
               </a:rPr>
-              <a:t>0.217</a:t>
+              <a:t>0.237</a:t>
             </a:r>
             <a:endParaRPr lang="en-US" sz="4800" dirty="0"/>
           </a:p>
@@ -11127,7 +11127,7 @@
                   <a:schemeClr val="accent5"/>
                 </a:solidFill>
               </a:rPr>
-              <a:t>95% CI of the gain [0.023, 0.035]</a:t>
+              <a:t>95% CI of the gain [0.043, 0.055]</a:t>
             </a:r>
             <a:endParaRPr lang="en-US" sz="1400" dirty="0"/>
           </a:p>
@@ -11163,7 +11163,7 @@
                   <a:schemeClr val="accent5"/>
                 </a:solidFill>
               </a:rPr>
-              <a:t>Measured, real baskets. Shortlist recall@100 = 58.0%, which caps any ranker.</a:t>
+              <a:t>Measured, real baskets. Shortlist recall@150 = 65.3% (was 58.0% at 100), which caps any ranker.</a:t>
             </a:r>
             <a:endParaRPr lang="en-US" sz="1000" dirty="0"/>
           </a:p>
@@ -11329,7 +11329,7 @@
                 <a:ea typeface="Cambria" pitchFamily="34" charset="-122"/>
                 <a:cs typeface="Cambria" pitchFamily="34" charset="-120"/>
               </a:rPr>
-              <a:t>+17%</a:t>
+              <a:t>+14%</a:t>
             </a:r>
             <a:endParaRPr lang="en-US" sz="4800" dirty="0"/>
           </a:p>
@@ -11418,7 +11418,7 @@
                 <a:ea typeface="Cambria" pitchFamily="34" charset="-122"/>
                 <a:cs typeface="Cambria" pitchFamily="34" charset="-120"/>
               </a:rPr>
-              <a:t>+22%</a:t>
+              <a:t>+24%</a:t>
             </a:r>
             <a:endParaRPr lang="en-US" sz="4800" dirty="0"/>
           </a:p>
@@ -11454,7 +11454,7 @@
                   <a:schemeClr val="accent5"/>
                 </a:solidFill>
               </a:rPr>
-              <a:t>profit at λ=1.0, for 3.7 pts fewer hits</a:t>
+              <a:t>profit at λ=1.0, for 2.9 pts fewer hits</a:t>
             </a:r>
             <a:endParaRPr lang="en-US" sz="1400" dirty="0"/>
           </a:p>
@@ -11529,7 +11529,7 @@
                   <a:schemeClr val="accent5"/>
                 </a:solidFill>
               </a:rPr>
-              <a:t>margin-floor breaks, vs 0.038 per basket</a:t>
+              <a:t>margin-floor breaks, vs 0.037 per basket</a:t>
             </a:r>
             <a:endParaRPr lang="en-US" sz="1400" dirty="0"/>
           </a:p>
@@ -11867,7 +11867,7 @@
                   <a:schemeClr val="accent5"/>
                 </a:solidFill>
               </a:rPr>
-              <a:t>3 margin distributions × 3 seeds; gain +£0.015 to +£0.062 per basket, every CI above zero</a:t>
+              <a:t>3 margin distributions × 3 seeds; gain +£0.024 to +£0.071 per basket, every CI above zero</a:t>
             </a:r>
             <a:endParaRPr lang="en-US" sz="1400" dirty="0"/>
           </a:p>
@@ -12149,7 +12149,7 @@
                 <a:ea typeface="Cambria" pitchFamily="34" charset="-122"/>
                 <a:cs typeface="Cambria" pitchFamily="34" charset="-120"/>
               </a:rPr>
-              <a:t>3.4 ms</a:t>
+              <a:t>2.7 ms</a:t>
             </a:r>
             <a:endParaRPr lang="en-US" sz="3000" dirty="0"/>
           </a:p>
@@ -12221,7 +12221,7 @@
                   <a:schemeClr val="accent5"/>
                 </a:solidFill>
               </a:rPr>
-              <a:t>Solver step only; end-to-end API latency is not benchmarked yet</a:t>
+              <a:t>Solver step; the API measured p50 22 ms in a container</a:t>
             </a:r>
             <a:endParaRPr lang="en-US" sz="1400" dirty="0"/>
           </a:p>
@@ -12326,7 +12326,7 @@
                 <a:ea typeface="Cambria" pitchFamily="34" charset="-122"/>
                 <a:cs typeface="Cambria" pitchFamily="34" charset="-120"/>
               </a:rPr>
-              <a:t>114 vs 74</a:t>
+              <a:t>116 vs 78</a:t>
             </a:r>
             <a:endParaRPr lang="en-US" sz="3000" dirty="0"/>
           </a:p>

</xml_diff>

<commit_message>
Record the E6 fine-tune NO-GO across README, roadmap, report, deck, launch kit and industry plan; point Kaggle notebooks at main; rebuild paper PDF
</commit_message>
<xml_diff>
--- a/docs/deck/MarginGraph_pitch_deck.pptx
+++ b/docs/deck/MarginGraph_pitch_deck.pptx
@@ -121,23 +121,23 @@
   <p:extLst>
     <p:ext uri="{521415D9-36F7-43E2-AB2F-B90AF26B5E84}">
       <p14:sectionLst xmlns:p14="http://schemas.microsoft.com/office/powerpoint/2010/main">
-        <p14:section name="Opening" id="{d5e93613-ab4b-7fb3-3096-c1df4cdfe593}">
+        <p14:section name="Opening" id="{2a3c0de6-9036-ef28-999d-f34a0af1c273}">
           <p14:sldIdLst>
             <p14:sldId id="256"/>
           </p14:sldIdLst>
         </p14:section>
-        <p14:section name="Problem and solution" id="{64c9fc9e-230a-cc78-f96b-ca828d8894c0}">
+        <p14:section name="Problem and solution" id="{5ababc16-2370-8796-0469-073e2adba84d}">
           <p14:sldIdLst>
             <p14:sldId id="257"/>
             <p14:sldId id="258"/>
           </p14:sldIdLst>
         </p14:section>
-        <p14:section name="How it works" id="{0c4803e0-5f9a-b498-a5de-53705abb4c61}">
+        <p14:section name="How it works" id="{2dcc39f1-5393-1d4b-ffbf-0b6982268a1d}">
           <p14:sldIdLst>
             <p14:sldId id="259"/>
           </p14:sldIdLst>
         </p14:section>
-        <p14:section name="Results" id="{b927d42b-fbb6-8260-9988-cc39f52e9a1e}">
+        <p14:section name="Results" id="{1310cfb9-8aaf-60d4-9a10-b372c42e73cc}">
           <p14:sldIdLst>
             <p14:sldId id="260"/>
             <p14:sldId id="261"/>
@@ -146,20 +146,20 @@
             <p14:sldId id="264"/>
           </p14:sldIdLst>
         </p14:section>
-        <p14:section name="Product" id="{cc6acd20-74e7-ce24-6e18-4d032c0392b7}">
+        <p14:section name="Product" id="{4b74233b-2325-8c59-4495-c6e2404a0e08}">
           <p14:sldIdLst>
             <p14:sldId id="265"/>
             <p14:sldId id="266"/>
           </p14:sldIdLst>
         </p14:section>
-        <p14:section name="Business and plan" id="{08a1cff4-16cd-483b-8942-ee81f1ebb871}">
+        <p14:section name="Business and plan" id="{f5019b4f-f4bb-402f-5532-0f6f9543a5c6}">
           <p14:sldIdLst>
             <p14:sldId id="267"/>
             <p14:sldId id="268"/>
             <p14:sldId id="269"/>
           </p14:sldIdLst>
         </p14:section>
-        <p14:section name="Close" id="{c825e8ca-6577-3487-b55d-8bf62607aee0}">
+        <p14:section name="Close" id="{1873ae5a-ebf6-0fc4-9b42-81369446495b}">
           <p14:sldIdLst>
             <p14:sldId id="270"/>
           </p14:sldIdLst>
@@ -6188,7 +6188,7 @@
                   <a:schemeClr val="tx1"/>
                 </a:solidFill>
               </a:rPr>
-              <a:t>LoRA fine-tune run, API latency benchmarked</a:t>
+              <a:t>Fine-tune run (NO-GO), API latency benchmarked</a:t>
             </a:r>
             <a:endParaRPr lang="en-US" sz="1400" dirty="0"/>
           </a:p>
@@ -14040,7 +14040,7 @@
                   <a:schemeClr val="accent1"/>
                 </a:solidFill>
               </a:rPr>
-              <a:t>Next: a LoRA fine-tune on free Kaggle GPUs. If it also loses, the LLM's role is new products and plain-language explanations, not ranking.</a:t>
+              <a:t>A LoRA fine-tune also lost (Hit@5 7.8%, below random order). The LLM's role is new products and plain-language explanations, not ranking.</a:t>
             </a:r>
             <a:endParaRPr lang="en-US" sz="1300" dirty="0"/>
           </a:p>

</xml_diff>